<commit_message>
Add: Accelerated HPO result slides
</commit_message>
<xml_diff>
--- a/presentation/Presentation.pptx
+++ b/presentation/Presentation.pptx
@@ -6,7 +6,7 @@
     <p:sldMasterId id="2147483671" r:id="rId2"/>
   </p:sldMasterIdLst>
   <p:notesMasterIdLst>
-    <p:notesMasterId r:id="rId31"/>
+    <p:notesMasterId r:id="rId34"/>
   </p:notesMasterIdLst>
   <p:sldIdLst>
     <p:sldId id="280" r:id="rId3"/>
@@ -36,7 +36,10 @@
     <p:sldId id="296" r:id="rId27"/>
     <p:sldId id="297" r:id="rId28"/>
     <p:sldId id="298" r:id="rId29"/>
-    <p:sldId id="269" r:id="rId30"/>
+    <p:sldId id="309" r:id="rId30"/>
+    <p:sldId id="310" r:id="rId31"/>
+    <p:sldId id="311" r:id="rId32"/>
+    <p:sldId id="269" r:id="rId33"/>
   </p:sldIdLst>
   <p:sldSz cx="12192000" cy="6858000"/>
   <p:notesSz cx="6858000" cy="9144000"/>
@@ -256,7 +259,7 @@
           <a:p>
             <a:fld id="{CF93AEB5-C303-4762-90A0-AF697EB357C4}" type="datetimeFigureOut">
               <a:rPr lang="de-DE" smtClean="0"/>
-              <a:t>10.01.26</a:t>
+              <a:t>15.01.26</a:t>
             </a:fld>
             <a:endParaRPr lang="de-DE"/>
           </a:p>
@@ -1166,7 +1169,7 @@
           <a:p>
             <a:fld id="{590C587F-9620-41AA-8442-404D6D597627}" type="slidenum">
               <a:rPr lang="de-DE" smtClean="0"/>
-              <a:t>28</a:t>
+              <a:t>31</a:t>
             </a:fld>
             <a:endParaRPr lang="de-DE"/>
           </a:p>
@@ -19249,10 +19252,10 @@
       </p:sp>
       <p:sp>
         <p:nvSpPr>
-          <p:cNvPr id="3" name="Textplatzhalter 2">
+          <p:cNvPr id="4" name="Textplatzhalter 3">
             <a:extLst>
               <a:ext uri="{FF2B5EF4-FFF2-40B4-BE49-F238E27FC236}">
-                <a16:creationId xmlns:a16="http://schemas.microsoft.com/office/drawing/2014/main" id="{896B85A3-79FA-E87C-E50F-E874A1E14AFF}"/>
+                <a16:creationId xmlns:a16="http://schemas.microsoft.com/office/drawing/2014/main" id="{8BB33ED0-C574-8A46-D62B-6AF45DC6B495}"/>
               </a:ext>
             </a:extLst>
           </p:cNvPr>
@@ -19268,10 +19271,7 @@
           <a:bodyPr/>
           <a:lstStyle/>
           <a:p>
-            <a:r>
-              <a:rPr lang="en-US" noProof="0" dirty="0"/>
-              <a:t>Getting data into the quantum state.</a:t>
-            </a:r>
+            <a:endParaRPr lang="en-US"/>
           </a:p>
         </p:txBody>
       </p:sp>
@@ -20365,10 +20365,10 @@
       </p:sp>
       <p:sp>
         <p:nvSpPr>
-          <p:cNvPr id="7" name="Vertikaler Textplatzhalter 6">
+          <p:cNvPr id="3" name="Textplatzhalter 2">
             <a:extLst>
               <a:ext uri="{FF2B5EF4-FFF2-40B4-BE49-F238E27FC236}">
-                <a16:creationId xmlns:a16="http://schemas.microsoft.com/office/drawing/2014/main" id="{1CA48D2D-8F49-F0A9-ADEE-25DBFCEEF10E}"/>
+                <a16:creationId xmlns:a16="http://schemas.microsoft.com/office/drawing/2014/main" id="{13EE501E-550F-5D40-01B8-E7B196F48F10}"/>
               </a:ext>
             </a:extLst>
           </p:cNvPr>
@@ -20376,7 +20376,7 @@
             <a:spLocks noGrp="1"/>
           </p:cNvSpPr>
           <p:nvPr>
-            <p:ph type="body" orient="vert" idx="13"/>
+            <p:ph type="body" idx="13"/>
           </p:nvPr>
         </p:nvSpPr>
         <p:spPr/>
@@ -20384,10 +20384,7 @@
           <a:bodyPr/>
           <a:lstStyle/>
           <a:p>
-            <a:r>
-              <a:rPr lang="en-US" noProof="0" dirty="0"/>
-              <a:t>Finding the best way to measure.</a:t>
-            </a:r>
+            <a:endParaRPr lang="en-US"/>
           </a:p>
         </p:txBody>
       </p:sp>
@@ -20552,8 +20549,8 @@
           </a:p>
         </p:txBody>
       </p:sp>
-      <mc:AlternateContent xmlns:mc="http://schemas.openxmlformats.org/markup-compatibility/2006">
-        <mc:Choice xmlns:a14="http://schemas.microsoft.com/office/drawing/2010/main" Requires="a14">
+      <mc:AlternateContent xmlns:mc="http://schemas.openxmlformats.org/markup-compatibility/2006" xmlns:a14="http://schemas.microsoft.com/office/drawing/2010/main">
+        <mc:Choice Requires="a14">
           <p:sp>
             <p:nvSpPr>
               <p:cNvPr id="3" name="Inhaltsplatzhalter 2">
@@ -20862,7 +20859,7 @@
             </p:txBody>
           </p:sp>
         </mc:Choice>
-        <mc:Fallback>
+        <mc:Fallback xmlns="">
           <p:sp>
             <p:nvSpPr>
               <p:cNvPr id="3" name="Inhaltsplatzhalter 2">
@@ -21132,8 +21129,8 @@
           <a:chExt cx="0" cy="0"/>
         </a:xfrm>
       </p:grpSpPr>
-      <mc:AlternateContent xmlns:mc="http://schemas.openxmlformats.org/markup-compatibility/2006">
-        <mc:Choice xmlns:a14="http://schemas.microsoft.com/office/drawing/2010/main" Requires="a14">
+      <mc:AlternateContent xmlns:mc="http://schemas.openxmlformats.org/markup-compatibility/2006" xmlns:a14="http://schemas.microsoft.com/office/drawing/2010/main">
+        <mc:Choice Requires="a14">
           <p:sp>
             <p:nvSpPr>
               <p:cNvPr id="15" name="Inhaltsplatzhalter 14">
@@ -21286,7 +21283,7 @@
             </p:txBody>
           </p:sp>
         </mc:Choice>
-        <mc:Fallback>
+        <mc:Fallback xmlns="">
           <p:sp>
             <p:nvSpPr>
               <p:cNvPr id="15" name="Inhaltsplatzhalter 14">
@@ -22315,8 +22312,8 @@
           </a:prstGeom>
         </p:spPr>
       </p:pic>
-      <mc:AlternateContent xmlns:mc="http://schemas.openxmlformats.org/markup-compatibility/2006">
-        <mc:Choice xmlns:a14="http://schemas.microsoft.com/office/drawing/2010/main" Requires="a14">
+      <mc:AlternateContent xmlns:mc="http://schemas.openxmlformats.org/markup-compatibility/2006" xmlns:a14="http://schemas.microsoft.com/office/drawing/2010/main">
+        <mc:Choice Requires="a14">
           <p:sp>
             <p:nvSpPr>
               <p:cNvPr id="10" name="Inhaltsplatzhalter 5">
@@ -22602,7 +22599,7 @@
             </p:txBody>
           </p:sp>
         </mc:Choice>
-        <mc:Fallback>
+        <mc:Fallback xmlns="">
           <p:sp>
             <p:nvSpPr>
               <p:cNvPr id="10" name="Inhaltsplatzhalter 5">
@@ -22810,10 +22807,10 @@
       </p:sp>
       <p:sp>
         <p:nvSpPr>
-          <p:cNvPr id="7" name="Vertikaler Textplatzhalter 6">
+          <p:cNvPr id="3" name="Textplatzhalter 2">
             <a:extLst>
               <a:ext uri="{FF2B5EF4-FFF2-40B4-BE49-F238E27FC236}">
-                <a16:creationId xmlns:a16="http://schemas.microsoft.com/office/drawing/2014/main" id="{AC87C0F3-6EB1-2534-14BE-E4A339417D0A}"/>
+                <a16:creationId xmlns:a16="http://schemas.microsoft.com/office/drawing/2014/main" id="{94B1F58A-4ED1-0CC6-CB9C-789D7A2941D3}"/>
               </a:ext>
             </a:extLst>
           </p:cNvPr>
@@ -22821,7 +22818,7 @@
             <a:spLocks noGrp="1"/>
           </p:cNvSpPr>
           <p:nvPr>
-            <p:ph type="body" orient="vert" idx="13"/>
+            <p:ph type="body" idx="13"/>
           </p:nvPr>
         </p:nvSpPr>
         <p:spPr/>
@@ -22829,10 +22826,7 @@
           <a:bodyPr/>
           <a:lstStyle/>
           <a:p>
-            <a:r>
-              <a:rPr lang="en-US" noProof="0" dirty="0"/>
-              <a:t>Bringing it all together.</a:t>
-            </a:r>
+            <a:endParaRPr lang="en-US"/>
           </a:p>
         </p:txBody>
       </p:sp>
@@ -23136,8 +23130,8 @@
           </a:ln>
         </p:spPr>
       </p:pic>
-      <mc:AlternateContent xmlns:mc="http://schemas.openxmlformats.org/markup-compatibility/2006">
-        <mc:Choice xmlns:a14="http://schemas.microsoft.com/office/drawing/2010/main" Requires="a14">
+      <mc:AlternateContent xmlns:mc="http://schemas.openxmlformats.org/markup-compatibility/2006" xmlns:a14="http://schemas.microsoft.com/office/drawing/2010/main">
+        <mc:Choice Requires="a14">
           <p:sp>
             <p:nvSpPr>
               <p:cNvPr id="10" name="Textfeld 9">
@@ -23169,6 +23163,7 @@
               </a:bodyPr>
               <a:lstStyle/>
               <a:p>
+                <a:pPr/>
                 <a14:m>
                   <m:oMathPara xmlns:m="http://schemas.openxmlformats.org/officeDocument/2006/math">
                     <m:oMathParaPr>
@@ -23954,7 +23949,7 @@
             </p:txBody>
           </p:sp>
         </mc:Choice>
-        <mc:Fallback>
+        <mc:Fallback xmlns="">
           <p:sp>
             <p:nvSpPr>
               <p:cNvPr id="10" name="Textfeld 9">
@@ -24931,7 +24926,7 @@
             <p:ph idx="13"/>
             <p:extLst>
               <p:ext uri="{D42A27DB-BD31-4B8C-83A1-F6EECF244321}">
-                <p14:modId xmlns:p14="http://schemas.microsoft.com/office/powerpoint/2010/main" val="1050495104"/>
+                <p14:modId xmlns:p14="http://schemas.microsoft.com/office/powerpoint/2010/main" val="897230473"/>
               </p:ext>
             </p:extLst>
           </p:nvPr>
@@ -25398,7 +25393,7 @@
                     <a:p>
                       <a:r>
                         <a:rPr lang="en-US" noProof="0" dirty="0"/>
-                        <a:t>1.5 s</a:t>
+                        <a:t>3.5 s</a:t>
                       </a:r>
                     </a:p>
                   </a:txBody>
@@ -25471,7 +25466,7 @@
                     <a:p>
                       <a:r>
                         <a:rPr lang="en-US" noProof="0" dirty="0"/>
-                        <a:t>20 m</a:t>
+                        <a:t>10 m</a:t>
                       </a:r>
                     </a:p>
                   </a:txBody>
@@ -26382,10 +26377,10 @@
       </p:sp>
       <p:sp>
         <p:nvSpPr>
-          <p:cNvPr id="7" name="Vertikaler Textplatzhalter 6">
+          <p:cNvPr id="3" name="Textplatzhalter 2">
             <a:extLst>
               <a:ext uri="{FF2B5EF4-FFF2-40B4-BE49-F238E27FC236}">
-                <a16:creationId xmlns:a16="http://schemas.microsoft.com/office/drawing/2014/main" id="{DDE32119-6BA8-B2AA-7117-ADEF465A20AE}"/>
+                <a16:creationId xmlns:a16="http://schemas.microsoft.com/office/drawing/2014/main" id="{D1F5D02B-45C5-E089-3E20-D22876474498}"/>
               </a:ext>
             </a:extLst>
           </p:cNvPr>
@@ -26393,7 +26388,7 @@
             <a:spLocks noGrp="1"/>
           </p:cNvSpPr>
           <p:nvPr>
-            <p:ph type="body" orient="vert" idx="13"/>
+            <p:ph type="body" idx="13"/>
           </p:nvPr>
         </p:nvSpPr>
         <p:spPr/>
@@ -26401,10 +26396,7 @@
           <a:bodyPr/>
           <a:lstStyle/>
           <a:p>
-            <a:r>
-              <a:rPr lang="en-US" noProof="0" dirty="0"/>
-              <a:t>Speeding up the optimization.</a:t>
-            </a:r>
+            <a:endParaRPr lang="en-US"/>
           </a:p>
         </p:txBody>
       </p:sp>
@@ -26569,8 +26561,8 @@
           </a:p>
         </p:txBody>
       </p:sp>
-      <mc:AlternateContent xmlns:mc="http://schemas.openxmlformats.org/markup-compatibility/2006">
-        <mc:Choice xmlns:a14="http://schemas.microsoft.com/office/drawing/2010/main" Requires="a14">
+      <mc:AlternateContent xmlns:mc="http://schemas.openxmlformats.org/markup-compatibility/2006" xmlns:a14="http://schemas.microsoft.com/office/drawing/2010/main">
+        <mc:Choice Requires="a14">
           <p:sp>
             <p:nvSpPr>
               <p:cNvPr id="14" name="Inhaltsplatzhalter 13">
@@ -27347,7 +27339,7 @@
             </p:txBody>
           </p:sp>
         </mc:Choice>
-        <mc:Fallback>
+        <mc:Fallback xmlns="">
           <p:sp>
             <p:nvSpPr>
               <p:cNvPr id="14" name="Inhaltsplatzhalter 13">
@@ -27628,6 +27620,887 @@
   <p:cSld>
     <p:spTree>
       <p:nvGrpSpPr>
+        <p:cNvPr id="1" name="">
+          <a:extLst>
+            <a:ext uri="{FF2B5EF4-FFF2-40B4-BE49-F238E27FC236}">
+              <a16:creationId xmlns:a16="http://schemas.microsoft.com/office/drawing/2014/main" id="{30AA123D-4611-F4EC-B424-0FFE9DB5CDFE}"/>
+            </a:ext>
+          </a:extLst>
+        </p:cNvPr>
+        <p:cNvGrpSpPr/>
+        <p:nvPr/>
+      </p:nvGrpSpPr>
+      <p:grpSpPr>
+        <a:xfrm>
+          <a:off x="0" y="0"/>
+          <a:ext cx="0" cy="0"/>
+          <a:chOff x="0" y="0"/>
+          <a:chExt cx="0" cy="0"/>
+        </a:xfrm>
+      </p:grpSpPr>
+      <p:sp>
+        <p:nvSpPr>
+          <p:cNvPr id="11" name="Datumsplatzhalter 10">
+            <a:extLst>
+              <a:ext uri="{FF2B5EF4-FFF2-40B4-BE49-F238E27FC236}">
+                <a16:creationId xmlns:a16="http://schemas.microsoft.com/office/drawing/2014/main" id="{CABCEE77-348F-8F67-A163-F375E22E445B}"/>
+              </a:ext>
+            </a:extLst>
+          </p:cNvPr>
+          <p:cNvSpPr>
+            <a:spLocks noGrp="1"/>
+          </p:cNvSpPr>
+          <p:nvPr>
+            <p:ph type="dt" sz="half" idx="10"/>
+          </p:nvPr>
+        </p:nvSpPr>
+        <p:spPr/>
+        <p:txBody>
+          <a:bodyPr/>
+          <a:lstStyle/>
+          <a:p>
+            <a:r>
+              <a:rPr lang="en-US" noProof="0" dirty="0"/>
+              <a:t>Campus Sontheim</a:t>
+            </a:r>
+          </a:p>
+        </p:txBody>
+      </p:sp>
+      <p:sp>
+        <p:nvSpPr>
+          <p:cNvPr id="12" name="Fußzeilenplatzhalter 11">
+            <a:extLst>
+              <a:ext uri="{FF2B5EF4-FFF2-40B4-BE49-F238E27FC236}">
+                <a16:creationId xmlns:a16="http://schemas.microsoft.com/office/drawing/2014/main" id="{31867FBE-6A1C-840E-0BCE-4C8630B0011E}"/>
+              </a:ext>
+            </a:extLst>
+          </p:cNvPr>
+          <p:cNvSpPr>
+            <a:spLocks noGrp="1"/>
+          </p:cNvSpPr>
+          <p:nvPr>
+            <p:ph type="ftr" sz="quarter" idx="11"/>
+          </p:nvPr>
+        </p:nvSpPr>
+        <p:spPr/>
+        <p:txBody>
+          <a:bodyPr/>
+          <a:lstStyle/>
+          <a:p>
+            <a:r>
+              <a:rPr lang="en-US" noProof="0" dirty="0"/>
+              <a:t>Nico Hofmann | M.Sc. Software Engineering | Winter Semester 2025/26</a:t>
+            </a:r>
+          </a:p>
+        </p:txBody>
+      </p:sp>
+      <p:sp>
+        <p:nvSpPr>
+          <p:cNvPr id="13" name="Foliennummernplatzhalter 12">
+            <a:extLst>
+              <a:ext uri="{FF2B5EF4-FFF2-40B4-BE49-F238E27FC236}">
+                <a16:creationId xmlns:a16="http://schemas.microsoft.com/office/drawing/2014/main" id="{CE9545BA-428E-8F00-3CCF-410D8E636A22}"/>
+              </a:ext>
+            </a:extLst>
+          </p:cNvPr>
+          <p:cNvSpPr>
+            <a:spLocks noGrp="1"/>
+          </p:cNvSpPr>
+          <p:nvPr>
+            <p:ph type="sldNum" sz="quarter" idx="12"/>
+          </p:nvPr>
+        </p:nvSpPr>
+        <p:spPr/>
+        <p:txBody>
+          <a:bodyPr/>
+          <a:lstStyle/>
+          <a:p>
+            <a:r>
+              <a:rPr lang="en-US" noProof="0" dirty="0"/>
+              <a:t>|  </a:t>
+            </a:r>
+            <a:fld id="{E6B5151A-17C4-4431-8407-112C0160A8B6}" type="slidenum">
+              <a:rPr lang="en-US" noProof="0" smtClean="0"/>
+              <a:pPr/>
+              <a:t>28</a:t>
+            </a:fld>
+            <a:endParaRPr lang="en-US" noProof="0" dirty="0"/>
+          </a:p>
+        </p:txBody>
+      </p:sp>
+      <p:sp>
+        <p:nvSpPr>
+          <p:cNvPr id="7" name="Titel 6">
+            <a:extLst>
+              <a:ext uri="{FF2B5EF4-FFF2-40B4-BE49-F238E27FC236}">
+                <a16:creationId xmlns:a16="http://schemas.microsoft.com/office/drawing/2014/main" id="{30B749F7-3761-B9F7-C426-09A50285A708}"/>
+              </a:ext>
+            </a:extLst>
+          </p:cNvPr>
+          <p:cNvSpPr>
+            <a:spLocks noGrp="1"/>
+          </p:cNvSpPr>
+          <p:nvPr>
+            <p:ph type="title"/>
+          </p:nvPr>
+        </p:nvSpPr>
+        <p:spPr/>
+        <p:txBody>
+          <a:bodyPr/>
+          <a:lstStyle/>
+          <a:p>
+            <a:r>
+              <a:rPr lang="en-US" noProof="0" dirty="0"/>
+              <a:t>(Optional) Accelerated</a:t>
+            </a:r>
+            <a:br>
+              <a:rPr lang="en-US" noProof="0" dirty="0"/>
+            </a:br>
+            <a:r>
+              <a:rPr lang="en-US" noProof="0" dirty="0"/>
+              <a:t>Hyperparameter Search</a:t>
+            </a:r>
+          </a:p>
+        </p:txBody>
+      </p:sp>
+      <p:pic>
+        <p:nvPicPr>
+          <p:cNvPr id="4" name="Inhaltsplatzhalter 3">
+            <a:extLst>
+              <a:ext uri="{FF2B5EF4-FFF2-40B4-BE49-F238E27FC236}">
+                <a16:creationId xmlns:a16="http://schemas.microsoft.com/office/drawing/2014/main" id="{E0E6FBAA-A0BF-58E1-D92A-D928C03E6571}"/>
+              </a:ext>
+            </a:extLst>
+          </p:cNvPr>
+          <p:cNvPicPr>
+            <a:picLocks noGrp="1" noChangeAspect="1"/>
+          </p:cNvPicPr>
+          <p:nvPr>
+            <p:ph idx="13"/>
+          </p:nvPr>
+        </p:nvPicPr>
+        <p:blipFill>
+          <a:blip r:embed="rId2"/>
+          <a:stretch>
+            <a:fillRect/>
+          </a:stretch>
+        </p:blipFill>
+        <p:spPr>
+          <a:xfrm>
+            <a:off x="406397" y="2163819"/>
+            <a:ext cx="7727267" cy="4083050"/>
+          </a:xfrm>
+          <a:prstGeom prst="rect">
+            <a:avLst/>
+          </a:prstGeom>
+        </p:spPr>
+      </p:pic>
+    </p:spTree>
+    <p:extLst>
+      <p:ext uri="{BB962C8B-B14F-4D97-AF65-F5344CB8AC3E}">
+        <p14:creationId xmlns:p14="http://schemas.microsoft.com/office/powerpoint/2010/main" val="1502865370"/>
+      </p:ext>
+    </p:extLst>
+  </p:cSld>
+  <p:clrMapOvr>
+    <a:masterClrMapping/>
+  </p:clrMapOvr>
+</p:sld>
+</file>
+
+<file path=ppt/slides/slide29.xml><?xml version="1.0" encoding="utf-8"?>
+<p:sld xmlns:a="http://schemas.openxmlformats.org/drawingml/2006/main" xmlns:r="http://schemas.openxmlformats.org/officeDocument/2006/relationships" xmlns:p="http://schemas.openxmlformats.org/presentationml/2006/main">
+  <p:cSld>
+    <p:spTree>
+      <p:nvGrpSpPr>
+        <p:cNvPr id="1" name="">
+          <a:extLst>
+            <a:ext uri="{FF2B5EF4-FFF2-40B4-BE49-F238E27FC236}">
+              <a16:creationId xmlns:a16="http://schemas.microsoft.com/office/drawing/2014/main" id="{0807D26D-D7EE-531F-2F65-DCF2300293E1}"/>
+            </a:ext>
+          </a:extLst>
+        </p:cNvPr>
+        <p:cNvGrpSpPr/>
+        <p:nvPr/>
+      </p:nvGrpSpPr>
+      <p:grpSpPr>
+        <a:xfrm>
+          <a:off x="0" y="0"/>
+          <a:ext cx="0" cy="0"/>
+          <a:chOff x="0" y="0"/>
+          <a:chExt cx="0" cy="0"/>
+        </a:xfrm>
+      </p:grpSpPr>
+      <p:sp>
+        <p:nvSpPr>
+          <p:cNvPr id="11" name="Datumsplatzhalter 10">
+            <a:extLst>
+              <a:ext uri="{FF2B5EF4-FFF2-40B4-BE49-F238E27FC236}">
+                <a16:creationId xmlns:a16="http://schemas.microsoft.com/office/drawing/2014/main" id="{9752BA6D-7660-B49F-4D9F-F42D655F6F60}"/>
+              </a:ext>
+            </a:extLst>
+          </p:cNvPr>
+          <p:cNvSpPr>
+            <a:spLocks noGrp="1"/>
+          </p:cNvSpPr>
+          <p:nvPr>
+            <p:ph type="dt" sz="half" idx="10"/>
+          </p:nvPr>
+        </p:nvSpPr>
+        <p:spPr/>
+        <p:txBody>
+          <a:bodyPr/>
+          <a:lstStyle/>
+          <a:p>
+            <a:r>
+              <a:rPr lang="en-US" noProof="0" dirty="0"/>
+              <a:t>Campus Sontheim</a:t>
+            </a:r>
+          </a:p>
+        </p:txBody>
+      </p:sp>
+      <p:sp>
+        <p:nvSpPr>
+          <p:cNvPr id="12" name="Fußzeilenplatzhalter 11">
+            <a:extLst>
+              <a:ext uri="{FF2B5EF4-FFF2-40B4-BE49-F238E27FC236}">
+                <a16:creationId xmlns:a16="http://schemas.microsoft.com/office/drawing/2014/main" id="{E7E5F55F-E413-D2E5-4D39-07BEC53485C3}"/>
+              </a:ext>
+            </a:extLst>
+          </p:cNvPr>
+          <p:cNvSpPr>
+            <a:spLocks noGrp="1"/>
+          </p:cNvSpPr>
+          <p:nvPr>
+            <p:ph type="ftr" sz="quarter" idx="11"/>
+          </p:nvPr>
+        </p:nvSpPr>
+        <p:spPr/>
+        <p:txBody>
+          <a:bodyPr/>
+          <a:lstStyle/>
+          <a:p>
+            <a:r>
+              <a:rPr lang="en-US" noProof="0" dirty="0"/>
+              <a:t>Nico Hofmann | M.Sc. Software Engineering | Winter Semester 2025/26</a:t>
+            </a:r>
+          </a:p>
+        </p:txBody>
+      </p:sp>
+      <p:sp>
+        <p:nvSpPr>
+          <p:cNvPr id="13" name="Foliennummernplatzhalter 12">
+            <a:extLst>
+              <a:ext uri="{FF2B5EF4-FFF2-40B4-BE49-F238E27FC236}">
+                <a16:creationId xmlns:a16="http://schemas.microsoft.com/office/drawing/2014/main" id="{CC0A4381-F2D9-A947-1F11-8C723E5FD911}"/>
+              </a:ext>
+            </a:extLst>
+          </p:cNvPr>
+          <p:cNvSpPr>
+            <a:spLocks noGrp="1"/>
+          </p:cNvSpPr>
+          <p:nvPr>
+            <p:ph type="sldNum" sz="quarter" idx="12"/>
+          </p:nvPr>
+        </p:nvSpPr>
+        <p:spPr/>
+        <p:txBody>
+          <a:bodyPr/>
+          <a:lstStyle/>
+          <a:p>
+            <a:r>
+              <a:rPr lang="en-US" noProof="0" dirty="0"/>
+              <a:t>|  </a:t>
+            </a:r>
+            <a:fld id="{E6B5151A-17C4-4431-8407-112C0160A8B6}" type="slidenum">
+              <a:rPr lang="en-US" noProof="0" smtClean="0"/>
+              <a:pPr/>
+              <a:t>29</a:t>
+            </a:fld>
+            <a:endParaRPr lang="en-US" noProof="0" dirty="0"/>
+          </a:p>
+        </p:txBody>
+      </p:sp>
+      <p:sp>
+        <p:nvSpPr>
+          <p:cNvPr id="7" name="Titel 6">
+            <a:extLst>
+              <a:ext uri="{FF2B5EF4-FFF2-40B4-BE49-F238E27FC236}">
+                <a16:creationId xmlns:a16="http://schemas.microsoft.com/office/drawing/2014/main" id="{D77F1DF3-1703-5193-6FAF-263A3E61A462}"/>
+              </a:ext>
+            </a:extLst>
+          </p:cNvPr>
+          <p:cNvSpPr>
+            <a:spLocks noGrp="1"/>
+          </p:cNvSpPr>
+          <p:nvPr>
+            <p:ph type="title"/>
+          </p:nvPr>
+        </p:nvSpPr>
+        <p:spPr/>
+        <p:txBody>
+          <a:bodyPr/>
+          <a:lstStyle/>
+          <a:p>
+            <a:r>
+              <a:rPr lang="en-US" noProof="0" dirty="0"/>
+              <a:t>(Optional) Accelerated</a:t>
+            </a:r>
+            <a:br>
+              <a:rPr lang="en-US" noProof="0" dirty="0"/>
+            </a:br>
+            <a:r>
+              <a:rPr lang="en-US" noProof="0" dirty="0"/>
+              <a:t>Hyperparameter Search</a:t>
+            </a:r>
+          </a:p>
+        </p:txBody>
+      </p:sp>
+      <p:pic>
+        <p:nvPicPr>
+          <p:cNvPr id="5" name="Inhaltsplatzhalter 4">
+            <a:extLst>
+              <a:ext uri="{FF2B5EF4-FFF2-40B4-BE49-F238E27FC236}">
+                <a16:creationId xmlns:a16="http://schemas.microsoft.com/office/drawing/2014/main" id="{20EFDC4C-31B0-D7F3-8593-357858AAFA13}"/>
+              </a:ext>
+            </a:extLst>
+          </p:cNvPr>
+          <p:cNvPicPr>
+            <a:picLocks noGrp="1" noChangeAspect="1"/>
+          </p:cNvPicPr>
+          <p:nvPr>
+            <p:ph idx="13"/>
+          </p:nvPr>
+        </p:nvPicPr>
+        <p:blipFill>
+          <a:blip r:embed="rId2"/>
+          <a:stretch>
+            <a:fillRect/>
+          </a:stretch>
+        </p:blipFill>
+        <p:spPr>
+          <a:xfrm>
+            <a:off x="406397" y="2163819"/>
+            <a:ext cx="7727267" cy="4083050"/>
+          </a:xfrm>
+          <a:prstGeom prst="rect">
+            <a:avLst/>
+          </a:prstGeom>
+        </p:spPr>
+      </p:pic>
+    </p:spTree>
+    <p:extLst>
+      <p:ext uri="{BB962C8B-B14F-4D97-AF65-F5344CB8AC3E}">
+        <p14:creationId xmlns:p14="http://schemas.microsoft.com/office/powerpoint/2010/main" val="3608072206"/>
+      </p:ext>
+    </p:extLst>
+  </p:cSld>
+  <p:clrMapOvr>
+    <a:masterClrMapping/>
+  </p:clrMapOvr>
+</p:sld>
+</file>
+
+<file path=ppt/slides/slide3.xml><?xml version="1.0" encoding="utf-8"?>
+<p:sld xmlns:a="http://schemas.openxmlformats.org/drawingml/2006/main" xmlns:r="http://schemas.openxmlformats.org/officeDocument/2006/relationships" xmlns:p="http://schemas.openxmlformats.org/presentationml/2006/main">
+  <p:cSld>
+    <p:spTree>
+      <p:nvGrpSpPr>
+        <p:cNvPr id="1" name=""/>
+        <p:cNvGrpSpPr/>
+        <p:nvPr/>
+      </p:nvGrpSpPr>
+      <p:grpSpPr>
+        <a:xfrm>
+          <a:off x="0" y="0"/>
+          <a:ext cx="0" cy="0"/>
+          <a:chOff x="0" y="0"/>
+          <a:chExt cx="0" cy="0"/>
+        </a:xfrm>
+      </p:grpSpPr>
+      <p:sp>
+        <p:nvSpPr>
+          <p:cNvPr id="12" name="Titel 11"/>
+          <p:cNvSpPr>
+            <a:spLocks noGrp="1"/>
+          </p:cNvSpPr>
+          <p:nvPr>
+            <p:ph type="ctrTitle"/>
+          </p:nvPr>
+        </p:nvSpPr>
+        <p:spPr/>
+        <p:txBody>
+          <a:bodyPr/>
+          <a:lstStyle/>
+          <a:p>
+            <a:r>
+              <a:rPr lang="en-US" noProof="0" dirty="0"/>
+              <a:t>Dataset</a:t>
+            </a:r>
+            <a:br>
+              <a:rPr lang="en-US" noProof="0" dirty="0"/>
+            </a:br>
+            <a:r>
+              <a:rPr lang="en-US" noProof="0" dirty="0"/>
+              <a:t>Exploration</a:t>
+            </a:r>
+          </a:p>
+        </p:txBody>
+      </p:sp>
+      <p:sp>
+        <p:nvSpPr>
+          <p:cNvPr id="11" name="Datumsplatzhalter 10">
+            <a:extLst>
+              <a:ext uri="{FF2B5EF4-FFF2-40B4-BE49-F238E27FC236}">
+                <a16:creationId xmlns:a16="http://schemas.microsoft.com/office/drawing/2014/main" id="{1157627F-B7DC-4EFF-BD81-1A592AB81FDE}"/>
+              </a:ext>
+            </a:extLst>
+          </p:cNvPr>
+          <p:cNvSpPr>
+            <a:spLocks noGrp="1"/>
+          </p:cNvSpPr>
+          <p:nvPr>
+            <p:ph type="dt" sz="half" idx="10"/>
+          </p:nvPr>
+        </p:nvSpPr>
+        <p:spPr/>
+        <p:txBody>
+          <a:bodyPr/>
+          <a:lstStyle/>
+          <a:p>
+            <a:r>
+              <a:rPr lang="en-US" noProof="0" dirty="0"/>
+              <a:t>Campus Sontheim</a:t>
+            </a:r>
+          </a:p>
+        </p:txBody>
+      </p:sp>
+      <p:sp>
+        <p:nvSpPr>
+          <p:cNvPr id="13" name="Fußzeilenplatzhalter 12">
+            <a:extLst>
+              <a:ext uri="{FF2B5EF4-FFF2-40B4-BE49-F238E27FC236}">
+                <a16:creationId xmlns:a16="http://schemas.microsoft.com/office/drawing/2014/main" id="{A5FA3907-DD6F-499A-A65E-989C1842BAD7}"/>
+              </a:ext>
+            </a:extLst>
+          </p:cNvPr>
+          <p:cNvSpPr>
+            <a:spLocks noGrp="1"/>
+          </p:cNvSpPr>
+          <p:nvPr>
+            <p:ph type="ftr" sz="quarter" idx="11"/>
+          </p:nvPr>
+        </p:nvSpPr>
+        <p:spPr/>
+        <p:txBody>
+          <a:bodyPr/>
+          <a:lstStyle/>
+          <a:p>
+            <a:r>
+              <a:rPr lang="en-US" noProof="0" dirty="0"/>
+              <a:t>Nico Hofmann | M.Sc. Software Engineering | Winter Semester 2025/26</a:t>
+            </a:r>
+          </a:p>
+        </p:txBody>
+      </p:sp>
+      <p:sp>
+        <p:nvSpPr>
+          <p:cNvPr id="14" name="Foliennummernplatzhalter 13">
+            <a:extLst>
+              <a:ext uri="{FF2B5EF4-FFF2-40B4-BE49-F238E27FC236}">
+                <a16:creationId xmlns:a16="http://schemas.microsoft.com/office/drawing/2014/main" id="{BE13F4B6-5C66-434E-98D4-89A7550EC872}"/>
+              </a:ext>
+            </a:extLst>
+          </p:cNvPr>
+          <p:cNvSpPr>
+            <a:spLocks noGrp="1"/>
+          </p:cNvSpPr>
+          <p:nvPr>
+            <p:ph type="sldNum" sz="quarter" idx="12"/>
+          </p:nvPr>
+        </p:nvSpPr>
+        <p:spPr/>
+        <p:txBody>
+          <a:bodyPr/>
+          <a:lstStyle/>
+          <a:p>
+            <a:r>
+              <a:rPr lang="en-US" noProof="0" dirty="0"/>
+              <a:t>|  </a:t>
+            </a:r>
+            <a:fld id="{E6B5151A-17C4-4431-8407-112C0160A8B6}" type="slidenum">
+              <a:rPr lang="en-US" noProof="0" smtClean="0"/>
+              <a:pPr/>
+              <a:t>3</a:t>
+            </a:fld>
+            <a:endParaRPr lang="en-US" noProof="0" dirty="0"/>
+          </a:p>
+        </p:txBody>
+      </p:sp>
+      <p:sp>
+        <p:nvSpPr>
+          <p:cNvPr id="3" name="Textplatzhalter 2">
+            <a:extLst>
+              <a:ext uri="{FF2B5EF4-FFF2-40B4-BE49-F238E27FC236}">
+                <a16:creationId xmlns:a16="http://schemas.microsoft.com/office/drawing/2014/main" id="{FE5C1DB5-9A72-AC25-1F09-8D0268AFAE09}"/>
+              </a:ext>
+            </a:extLst>
+          </p:cNvPr>
+          <p:cNvSpPr>
+            <a:spLocks noGrp="1"/>
+          </p:cNvSpPr>
+          <p:nvPr>
+            <p:ph type="body" idx="13"/>
+          </p:nvPr>
+        </p:nvSpPr>
+        <p:spPr/>
+        <p:txBody>
+          <a:bodyPr/>
+          <a:lstStyle/>
+          <a:p>
+            <a:endParaRPr lang="en-US"/>
+          </a:p>
+        </p:txBody>
+      </p:sp>
+    </p:spTree>
+    <p:extLst>
+      <p:ext uri="{BB962C8B-B14F-4D97-AF65-F5344CB8AC3E}">
+        <p14:creationId xmlns:p14="http://schemas.microsoft.com/office/powerpoint/2010/main" val="1503323803"/>
+      </p:ext>
+    </p:extLst>
+  </p:cSld>
+  <p:clrMapOvr>
+    <a:masterClrMapping/>
+  </p:clrMapOvr>
+</p:sld>
+</file>
+
+<file path=ppt/slides/slide30.xml><?xml version="1.0" encoding="utf-8"?>
+<p:sld xmlns:a="http://schemas.openxmlformats.org/drawingml/2006/main" xmlns:r="http://schemas.openxmlformats.org/officeDocument/2006/relationships" xmlns:p="http://schemas.openxmlformats.org/presentationml/2006/main">
+  <p:cSld>
+    <p:spTree>
+      <p:nvGrpSpPr>
+        <p:cNvPr id="1" name="">
+          <a:extLst>
+            <a:ext uri="{FF2B5EF4-FFF2-40B4-BE49-F238E27FC236}">
+              <a16:creationId xmlns:a16="http://schemas.microsoft.com/office/drawing/2014/main" id="{F7330251-B540-CFA5-D429-1420C9741329}"/>
+            </a:ext>
+          </a:extLst>
+        </p:cNvPr>
+        <p:cNvGrpSpPr/>
+        <p:nvPr/>
+      </p:nvGrpSpPr>
+      <p:grpSpPr>
+        <a:xfrm>
+          <a:off x="0" y="0"/>
+          <a:ext cx="0" cy="0"/>
+          <a:chOff x="0" y="0"/>
+          <a:chExt cx="0" cy="0"/>
+        </a:xfrm>
+      </p:grpSpPr>
+      <p:sp>
+        <p:nvSpPr>
+          <p:cNvPr id="11" name="Datumsplatzhalter 10">
+            <a:extLst>
+              <a:ext uri="{FF2B5EF4-FFF2-40B4-BE49-F238E27FC236}">
+                <a16:creationId xmlns:a16="http://schemas.microsoft.com/office/drawing/2014/main" id="{1FF52A39-1BED-7DF8-1B00-9D768A07F56B}"/>
+              </a:ext>
+            </a:extLst>
+          </p:cNvPr>
+          <p:cNvSpPr>
+            <a:spLocks noGrp="1"/>
+          </p:cNvSpPr>
+          <p:nvPr>
+            <p:ph type="dt" sz="half" idx="10"/>
+          </p:nvPr>
+        </p:nvSpPr>
+        <p:spPr/>
+        <p:txBody>
+          <a:bodyPr/>
+          <a:lstStyle/>
+          <a:p>
+            <a:r>
+              <a:rPr lang="en-US" noProof="0" dirty="0"/>
+              <a:t>Campus Sontheim</a:t>
+            </a:r>
+          </a:p>
+        </p:txBody>
+      </p:sp>
+      <p:sp>
+        <p:nvSpPr>
+          <p:cNvPr id="12" name="Fußzeilenplatzhalter 11">
+            <a:extLst>
+              <a:ext uri="{FF2B5EF4-FFF2-40B4-BE49-F238E27FC236}">
+                <a16:creationId xmlns:a16="http://schemas.microsoft.com/office/drawing/2014/main" id="{20F2679B-6C25-983A-1527-E7C0E14B73D8}"/>
+              </a:ext>
+            </a:extLst>
+          </p:cNvPr>
+          <p:cNvSpPr>
+            <a:spLocks noGrp="1"/>
+          </p:cNvSpPr>
+          <p:nvPr>
+            <p:ph type="ftr" sz="quarter" idx="11"/>
+          </p:nvPr>
+        </p:nvSpPr>
+        <p:spPr/>
+        <p:txBody>
+          <a:bodyPr/>
+          <a:lstStyle/>
+          <a:p>
+            <a:r>
+              <a:rPr lang="en-US" noProof="0" dirty="0"/>
+              <a:t>Nico Hofmann | M.Sc. Software Engineering | Winter Semester 2025/26</a:t>
+            </a:r>
+          </a:p>
+        </p:txBody>
+      </p:sp>
+      <p:sp>
+        <p:nvSpPr>
+          <p:cNvPr id="13" name="Foliennummernplatzhalter 12">
+            <a:extLst>
+              <a:ext uri="{FF2B5EF4-FFF2-40B4-BE49-F238E27FC236}">
+                <a16:creationId xmlns:a16="http://schemas.microsoft.com/office/drawing/2014/main" id="{02392F76-9CD0-9FFF-1611-D3585C0D853B}"/>
+              </a:ext>
+            </a:extLst>
+          </p:cNvPr>
+          <p:cNvSpPr>
+            <a:spLocks noGrp="1"/>
+          </p:cNvSpPr>
+          <p:nvPr>
+            <p:ph type="sldNum" sz="quarter" idx="12"/>
+          </p:nvPr>
+        </p:nvSpPr>
+        <p:spPr/>
+        <p:txBody>
+          <a:bodyPr/>
+          <a:lstStyle/>
+          <a:p>
+            <a:r>
+              <a:rPr lang="en-US" noProof="0" dirty="0"/>
+              <a:t>|  </a:t>
+            </a:r>
+            <a:fld id="{E6B5151A-17C4-4431-8407-112C0160A8B6}" type="slidenum">
+              <a:rPr lang="en-US" noProof="0" smtClean="0"/>
+              <a:pPr/>
+              <a:t>30</a:t>
+            </a:fld>
+            <a:endParaRPr lang="en-US" noProof="0" dirty="0"/>
+          </a:p>
+        </p:txBody>
+      </p:sp>
+      <p:sp>
+        <p:nvSpPr>
+          <p:cNvPr id="7" name="Titel 6">
+            <a:extLst>
+              <a:ext uri="{FF2B5EF4-FFF2-40B4-BE49-F238E27FC236}">
+                <a16:creationId xmlns:a16="http://schemas.microsoft.com/office/drawing/2014/main" id="{BB3D12D1-4675-15D6-7E2B-C44C86F9365F}"/>
+              </a:ext>
+            </a:extLst>
+          </p:cNvPr>
+          <p:cNvSpPr>
+            <a:spLocks noGrp="1"/>
+          </p:cNvSpPr>
+          <p:nvPr>
+            <p:ph type="title"/>
+          </p:nvPr>
+        </p:nvSpPr>
+        <p:spPr/>
+        <p:txBody>
+          <a:bodyPr/>
+          <a:lstStyle/>
+          <a:p>
+            <a:r>
+              <a:rPr lang="en-US" noProof="0" dirty="0"/>
+              <a:t>(Optional) Accelerated</a:t>
+            </a:r>
+            <a:br>
+              <a:rPr lang="en-US" noProof="0" dirty="0"/>
+            </a:br>
+            <a:r>
+              <a:rPr lang="en-US" noProof="0" dirty="0"/>
+              <a:t>Hyperparameter Search</a:t>
+            </a:r>
+          </a:p>
+        </p:txBody>
+      </p:sp>
+      <p:sp>
+        <p:nvSpPr>
+          <p:cNvPr id="3" name="Inhaltsplatzhalter 2">
+            <a:extLst>
+              <a:ext uri="{FF2B5EF4-FFF2-40B4-BE49-F238E27FC236}">
+                <a16:creationId xmlns:a16="http://schemas.microsoft.com/office/drawing/2014/main" id="{7D9B904B-F576-EC11-7FD6-A004F29E90D1}"/>
+              </a:ext>
+            </a:extLst>
+          </p:cNvPr>
+          <p:cNvSpPr>
+            <a:spLocks noGrp="1"/>
+          </p:cNvSpPr>
+          <p:nvPr>
+            <p:ph idx="13"/>
+          </p:nvPr>
+        </p:nvSpPr>
+        <p:spPr>
+          <a:xfrm>
+            <a:off x="406406" y="2160589"/>
+            <a:ext cx="6759326" cy="4083052"/>
+          </a:xfrm>
+        </p:spPr>
+        <p:txBody>
+          <a:bodyPr/>
+          <a:lstStyle/>
+          <a:p>
+            <a:pPr lvl="2"/>
+            <a:r>
+              <a:rPr lang="en-US" sz="2200" b="1" dirty="0">
+                <a:solidFill>
+                  <a:schemeClr val="tx1"/>
+                </a:solidFill>
+              </a:rPr>
+              <a:t>Outcome: </a:t>
+            </a:r>
+            <a:r>
+              <a:rPr lang="en-US" sz="2200" dirty="0">
+                <a:solidFill>
+                  <a:schemeClr val="tx1"/>
+                </a:solidFill>
+              </a:rPr>
+              <a:t>The</a:t>
+            </a:r>
+            <a:r>
+              <a:rPr lang="en-US" sz="2200" b="1" dirty="0">
+                <a:solidFill>
+                  <a:schemeClr val="tx1"/>
+                </a:solidFill>
+              </a:rPr>
+              <a:t> </a:t>
+            </a:r>
+            <a:r>
+              <a:rPr lang="en-US" sz="2200" dirty="0">
+                <a:solidFill>
+                  <a:schemeClr val="tx1"/>
+                </a:solidFill>
+              </a:rPr>
+              <a:t>accelerated hyperparameter search enabled more combinations of encoding circuits and observables to be tested, resulting in an even more accurate model.</a:t>
+            </a:r>
+            <a:endParaRPr lang="en-US" sz="2200" dirty="0"/>
+          </a:p>
+          <a:p>
+            <a:pPr lvl="3"/>
+            <a:r>
+              <a:rPr lang="en-US" sz="2200" dirty="0"/>
+              <a:t>Accuracy</a:t>
+            </a:r>
+          </a:p>
+          <a:p>
+            <a:pPr lvl="4"/>
+            <a:r>
+              <a:rPr lang="en-US" sz="2200" dirty="0"/>
+              <a:t>Train: 0.97 </a:t>
+            </a:r>
+            <a:r>
+              <a:rPr lang="en-US" sz="2200" dirty="0">
+                <a:solidFill>
+                  <a:schemeClr val="accent6"/>
+                </a:solidFill>
+              </a:rPr>
+              <a:t>(+0.02)</a:t>
+            </a:r>
+          </a:p>
+          <a:p>
+            <a:pPr lvl="4"/>
+            <a:r>
+              <a:rPr lang="en-US" sz="2200" dirty="0"/>
+              <a:t>Test: 0.97 </a:t>
+            </a:r>
+            <a:r>
+              <a:rPr lang="en-US" sz="2200" dirty="0">
+                <a:solidFill>
+                  <a:schemeClr val="accent6"/>
+                </a:solidFill>
+              </a:rPr>
+              <a:t>(+0.03)</a:t>
+            </a:r>
+          </a:p>
+        </p:txBody>
+      </p:sp>
+      <p:pic>
+        <p:nvPicPr>
+          <p:cNvPr id="4" name="Grafik 3">
+            <a:extLst>
+              <a:ext uri="{FF2B5EF4-FFF2-40B4-BE49-F238E27FC236}">
+                <a16:creationId xmlns:a16="http://schemas.microsoft.com/office/drawing/2014/main" id="{5054C6B2-7FB9-B1E8-BFF0-9158EFC9E06A}"/>
+              </a:ext>
+            </a:extLst>
+          </p:cNvPr>
+          <p:cNvPicPr>
+            <a:picLocks noChangeAspect="1"/>
+          </p:cNvPicPr>
+          <p:nvPr/>
+        </p:nvPicPr>
+        <p:blipFill>
+          <a:blip r:embed="rId2"/>
+          <a:stretch>
+            <a:fillRect/>
+          </a:stretch>
+        </p:blipFill>
+        <p:spPr>
+          <a:xfrm>
+            <a:off x="7101414" y="2167048"/>
+            <a:ext cx="4682075" cy="2034866"/>
+          </a:xfrm>
+          <a:prstGeom prst="rect">
+            <a:avLst/>
+          </a:prstGeom>
+        </p:spPr>
+      </p:pic>
+      <p:pic>
+        <p:nvPicPr>
+          <p:cNvPr id="6" name="Grafik 5">
+            <a:extLst>
+              <a:ext uri="{FF2B5EF4-FFF2-40B4-BE49-F238E27FC236}">
+                <a16:creationId xmlns:a16="http://schemas.microsoft.com/office/drawing/2014/main" id="{1F4F4AC0-8474-7315-3307-8625705D81E7}"/>
+              </a:ext>
+            </a:extLst>
+          </p:cNvPr>
+          <p:cNvPicPr>
+            <a:picLocks noChangeAspect="1"/>
+          </p:cNvPicPr>
+          <p:nvPr/>
+        </p:nvPicPr>
+        <p:blipFill>
+          <a:blip r:embed="rId3"/>
+          <a:stretch>
+            <a:fillRect/>
+          </a:stretch>
+        </p:blipFill>
+        <p:spPr>
+          <a:xfrm>
+            <a:off x="7391507" y="4220309"/>
+            <a:ext cx="4135676" cy="2034866"/>
+          </a:xfrm>
+          <a:prstGeom prst="rect">
+            <a:avLst/>
+          </a:prstGeom>
+        </p:spPr>
+      </p:pic>
+    </p:spTree>
+    <p:extLst>
+      <p:ext uri="{BB962C8B-B14F-4D97-AF65-F5344CB8AC3E}">
+        <p14:creationId xmlns:p14="http://schemas.microsoft.com/office/powerpoint/2010/main" val="3626747318"/>
+      </p:ext>
+    </p:extLst>
+  </p:cSld>
+  <p:clrMapOvr>
+    <a:masterClrMapping/>
+  </p:clrMapOvr>
+</p:sld>
+</file>
+
+<file path=ppt/slides/slide31.xml><?xml version="1.0" encoding="utf-8"?>
+<p:sld xmlns:a="http://schemas.openxmlformats.org/drawingml/2006/main" xmlns:r="http://schemas.openxmlformats.org/officeDocument/2006/relationships" xmlns:p="http://schemas.openxmlformats.org/presentationml/2006/main">
+  <p:cSld>
+    <p:spTree>
+      <p:nvGrpSpPr>
         <p:cNvPr id="1" name=""/>
         <p:cNvGrpSpPr/>
         <p:nvPr/>
@@ -27724,7 +28597,7 @@
             <a:fld id="{E6B5151A-17C4-4431-8407-112C0160A8B6}" type="slidenum">
               <a:rPr lang="en-US" noProof="0" smtClean="0"/>
               <a:pPr/>
-              <a:t>28</a:t>
+              <a:t>31</a:t>
             </a:fld>
             <a:endParaRPr lang="en-US" noProof="0" dirty="0"/>
           </a:p>
@@ -27853,177 +28726,6 @@
 </p:sld>
 </file>
 
-<file path=ppt/slides/slide3.xml><?xml version="1.0" encoding="utf-8"?>
-<p:sld xmlns:a="http://schemas.openxmlformats.org/drawingml/2006/main" xmlns:r="http://schemas.openxmlformats.org/officeDocument/2006/relationships" xmlns:p="http://schemas.openxmlformats.org/presentationml/2006/main">
-  <p:cSld>
-    <p:spTree>
-      <p:nvGrpSpPr>
-        <p:cNvPr id="1" name=""/>
-        <p:cNvGrpSpPr/>
-        <p:nvPr/>
-      </p:nvGrpSpPr>
-      <p:grpSpPr>
-        <a:xfrm>
-          <a:off x="0" y="0"/>
-          <a:ext cx="0" cy="0"/>
-          <a:chOff x="0" y="0"/>
-          <a:chExt cx="0" cy="0"/>
-        </a:xfrm>
-      </p:grpSpPr>
-      <p:sp>
-        <p:nvSpPr>
-          <p:cNvPr id="12" name="Titel 11"/>
-          <p:cNvSpPr>
-            <a:spLocks noGrp="1"/>
-          </p:cNvSpPr>
-          <p:nvPr>
-            <p:ph type="ctrTitle"/>
-          </p:nvPr>
-        </p:nvSpPr>
-        <p:spPr/>
-        <p:txBody>
-          <a:bodyPr/>
-          <a:lstStyle/>
-          <a:p>
-            <a:r>
-              <a:rPr lang="en-US" noProof="0" dirty="0"/>
-              <a:t>Dataset</a:t>
-            </a:r>
-            <a:br>
-              <a:rPr lang="en-US" noProof="0" dirty="0"/>
-            </a:br>
-            <a:r>
-              <a:rPr lang="en-US" noProof="0" dirty="0"/>
-              <a:t>Exploration</a:t>
-            </a:r>
-          </a:p>
-        </p:txBody>
-      </p:sp>
-      <p:sp>
-        <p:nvSpPr>
-          <p:cNvPr id="11" name="Datumsplatzhalter 10">
-            <a:extLst>
-              <a:ext uri="{FF2B5EF4-FFF2-40B4-BE49-F238E27FC236}">
-                <a16:creationId xmlns:a16="http://schemas.microsoft.com/office/drawing/2014/main" id="{1157627F-B7DC-4EFF-BD81-1A592AB81FDE}"/>
-              </a:ext>
-            </a:extLst>
-          </p:cNvPr>
-          <p:cNvSpPr>
-            <a:spLocks noGrp="1"/>
-          </p:cNvSpPr>
-          <p:nvPr>
-            <p:ph type="dt" sz="half" idx="10"/>
-          </p:nvPr>
-        </p:nvSpPr>
-        <p:spPr/>
-        <p:txBody>
-          <a:bodyPr/>
-          <a:lstStyle/>
-          <a:p>
-            <a:r>
-              <a:rPr lang="en-US" noProof="0" dirty="0"/>
-              <a:t>Campus Sontheim</a:t>
-            </a:r>
-          </a:p>
-        </p:txBody>
-      </p:sp>
-      <p:sp>
-        <p:nvSpPr>
-          <p:cNvPr id="13" name="Fußzeilenplatzhalter 12">
-            <a:extLst>
-              <a:ext uri="{FF2B5EF4-FFF2-40B4-BE49-F238E27FC236}">
-                <a16:creationId xmlns:a16="http://schemas.microsoft.com/office/drawing/2014/main" id="{A5FA3907-DD6F-499A-A65E-989C1842BAD7}"/>
-              </a:ext>
-            </a:extLst>
-          </p:cNvPr>
-          <p:cNvSpPr>
-            <a:spLocks noGrp="1"/>
-          </p:cNvSpPr>
-          <p:nvPr>
-            <p:ph type="ftr" sz="quarter" idx="11"/>
-          </p:nvPr>
-        </p:nvSpPr>
-        <p:spPr/>
-        <p:txBody>
-          <a:bodyPr/>
-          <a:lstStyle/>
-          <a:p>
-            <a:r>
-              <a:rPr lang="en-US" noProof="0" dirty="0"/>
-              <a:t>Nico Hofmann | M.Sc. Software Engineering | Winter Semester 2025/26</a:t>
-            </a:r>
-          </a:p>
-        </p:txBody>
-      </p:sp>
-      <p:sp>
-        <p:nvSpPr>
-          <p:cNvPr id="14" name="Foliennummernplatzhalter 13">
-            <a:extLst>
-              <a:ext uri="{FF2B5EF4-FFF2-40B4-BE49-F238E27FC236}">
-                <a16:creationId xmlns:a16="http://schemas.microsoft.com/office/drawing/2014/main" id="{BE13F4B6-5C66-434E-98D4-89A7550EC872}"/>
-              </a:ext>
-            </a:extLst>
-          </p:cNvPr>
-          <p:cNvSpPr>
-            <a:spLocks noGrp="1"/>
-          </p:cNvSpPr>
-          <p:nvPr>
-            <p:ph type="sldNum" sz="quarter" idx="12"/>
-          </p:nvPr>
-        </p:nvSpPr>
-        <p:spPr/>
-        <p:txBody>
-          <a:bodyPr/>
-          <a:lstStyle/>
-          <a:p>
-            <a:r>
-              <a:rPr lang="en-US" noProof="0" dirty="0"/>
-              <a:t>|  </a:t>
-            </a:r>
-            <a:fld id="{E6B5151A-17C4-4431-8407-112C0160A8B6}" type="slidenum">
-              <a:rPr lang="en-US" noProof="0" smtClean="0"/>
-              <a:pPr/>
-              <a:t>3</a:t>
-            </a:fld>
-            <a:endParaRPr lang="en-US" noProof="0" dirty="0"/>
-          </a:p>
-        </p:txBody>
-      </p:sp>
-      <p:sp>
-        <p:nvSpPr>
-          <p:cNvPr id="7" name="Vertikaler Textplatzhalter 6"/>
-          <p:cNvSpPr>
-            <a:spLocks noGrp="1"/>
-          </p:cNvSpPr>
-          <p:nvPr>
-            <p:ph type="body" orient="vert" idx="13"/>
-          </p:nvPr>
-        </p:nvSpPr>
-        <p:spPr/>
-        <p:txBody>
-          <a:bodyPr/>
-          <a:lstStyle/>
-          <a:p>
-            <a:r>
-              <a:rPr lang="en-US" noProof="0" dirty="0"/>
-              <a:t>Getting to know the data.</a:t>
-            </a:r>
-          </a:p>
-        </p:txBody>
-      </p:sp>
-    </p:spTree>
-    <p:extLst>
-      <p:ext uri="{BB962C8B-B14F-4D97-AF65-F5344CB8AC3E}">
-        <p14:creationId xmlns:p14="http://schemas.microsoft.com/office/powerpoint/2010/main" val="1503323803"/>
-      </p:ext>
-    </p:extLst>
-  </p:cSld>
-  <p:clrMapOvr>
-    <a:masterClrMapping/>
-  </p:clrMapOvr>
-</p:sld>
-</file>
-
 <file path=ppt/slides/slide4.xml><?xml version="1.0" encoding="utf-8"?>
 <p:sld xmlns:a="http://schemas.openxmlformats.org/drawingml/2006/main" xmlns:r="http://schemas.openxmlformats.org/officeDocument/2006/relationships" xmlns:p="http://schemas.openxmlformats.org/presentationml/2006/main">
   <p:cSld>
@@ -28172,8 +28874,8 @@
           </a:p>
         </p:txBody>
       </p:sp>
-      <mc:AlternateContent xmlns:mc="http://schemas.openxmlformats.org/markup-compatibility/2006">
-        <mc:Choice xmlns:a14="http://schemas.microsoft.com/office/drawing/2010/main" Requires="a14">
+      <mc:AlternateContent xmlns:mc="http://schemas.openxmlformats.org/markup-compatibility/2006" xmlns:a14="http://schemas.microsoft.com/office/drawing/2010/main">
+        <mc:Choice Requires="a14">
           <p:sp>
             <p:nvSpPr>
               <p:cNvPr id="14" name="Inhaltsplatzhalter 13">
@@ -28718,7 +29420,7 @@
             </p:txBody>
           </p:sp>
         </mc:Choice>
-        <mc:Fallback>
+        <mc:Fallback xmlns="">
           <p:sp>
             <p:nvSpPr>
               <p:cNvPr id="14" name="Inhaltsplatzhalter 13">
@@ -29014,8 +29716,8 @@
           </a:prstGeom>
         </p:spPr>
       </p:pic>
-      <mc:AlternateContent xmlns:mc="http://schemas.openxmlformats.org/markup-compatibility/2006">
-        <mc:Choice xmlns:a14="http://schemas.microsoft.com/office/drawing/2010/main" Requires="a14">
+      <mc:AlternateContent xmlns:mc="http://schemas.openxmlformats.org/markup-compatibility/2006" xmlns:a14="http://schemas.microsoft.com/office/drawing/2010/main">
+        <mc:Choice Requires="a14">
           <p:sp>
             <p:nvSpPr>
               <p:cNvPr id="3" name="Inhaltsplatzhalter 13">
@@ -29283,6 +29985,7 @@
                 </a:endParaRPr>
               </a:p>
               <a:p>
+                <a:pPr/>
                 <a14:m>
                   <m:oMathPara xmlns:m="http://schemas.openxmlformats.org/officeDocument/2006/math">
                     <m:oMathParaPr>
@@ -29321,7 +30024,7 @@
             </p:txBody>
           </p:sp>
         </mc:Choice>
-        <mc:Fallback>
+        <mc:Fallback xmlns="">
           <p:sp>
             <p:nvSpPr>
               <p:cNvPr id="3" name="Inhaltsplatzhalter 13">
@@ -29404,271 +30107,6 @@
       </p:grpSpPr>
       <p:sp>
         <p:nvSpPr>
-          <p:cNvPr id="5" name="Inhaltsplatzhalter 13">
-            <a:extLst>
-              <a:ext uri="{FF2B5EF4-FFF2-40B4-BE49-F238E27FC236}">
-                <a16:creationId xmlns:a16="http://schemas.microsoft.com/office/drawing/2014/main" id="{B53D698C-B26B-EE9F-32BF-6CF6F396809E}"/>
-              </a:ext>
-            </a:extLst>
-          </p:cNvPr>
-          <p:cNvSpPr txBox="1">
-            <a:spLocks/>
-          </p:cNvSpPr>
-          <p:nvPr/>
-        </p:nvSpPr>
-        <p:spPr>
-          <a:xfrm>
-            <a:off x="6095999" y="2312989"/>
-            <a:ext cx="5839889" cy="4083052"/>
-          </a:xfrm>
-          <a:prstGeom prst="rect">
-            <a:avLst/>
-          </a:prstGeom>
-        </p:spPr>
-        <p:txBody>
-          <a:bodyPr vert="horz" lIns="0" tIns="0" rIns="0" bIns="0" rtlCol="0" anchor="t" anchorCtr="0">
-            <a:noAutofit/>
-          </a:bodyPr>
-          <a:lstStyle>
-            <a:lvl1pPr marL="0" indent="0" algn="l" defTabSz="914407" rtl="0" eaLnBrk="1" latinLnBrk="0" hangingPunct="1">
-              <a:lnSpc>
-                <a:spcPct val="105000"/>
-              </a:lnSpc>
-              <a:spcBef>
-                <a:spcPts val="0"/>
-              </a:spcBef>
-              <a:spcAft>
-                <a:spcPts val="1999"/>
-              </a:spcAft>
-              <a:buFont typeface="Arial" panose="020B0604020202020204" pitchFamily="34" charset="0"/>
-              <a:buNone/>
-              <a:tabLst>
-                <a:tab pos="288003" algn="l"/>
-                <a:tab pos="792005" algn="l"/>
-              </a:tabLst>
-              <a:defRPr sz="2201" b="0" kern="1200" baseline="0">
-                <a:solidFill>
-                  <a:schemeClr val="tx1"/>
-                </a:solidFill>
-                <a:latin typeface="+mn-lt"/>
-                <a:ea typeface="+mn-ea"/>
-                <a:cs typeface="+mn-cs"/>
-              </a:defRPr>
-            </a:lvl1pPr>
-            <a:lvl2pPr marL="288003" indent="-288003" algn="l" defTabSz="914407" rtl="0" eaLnBrk="1" latinLnBrk="0" hangingPunct="1">
-              <a:lnSpc>
-                <a:spcPct val="105000"/>
-              </a:lnSpc>
-              <a:spcBef>
-                <a:spcPts val="599"/>
-              </a:spcBef>
-              <a:buClr>
-                <a:schemeClr val="accent1"/>
-              </a:buClr>
-              <a:buFont typeface="Arial" panose="020B0604020202020204" pitchFamily="34" charset="0"/>
-              <a:buChar char="&gt;"/>
-              <a:tabLst>
-                <a:tab pos="288003" algn="l"/>
-                <a:tab pos="792005" algn="l"/>
-              </a:tabLst>
-              <a:defRPr sz="2201" b="0" kern="1200">
-                <a:solidFill>
-                  <a:schemeClr val="tx1"/>
-                </a:solidFill>
-                <a:latin typeface="+mn-lt"/>
-                <a:ea typeface="+mn-ea"/>
-                <a:cs typeface="+mn-cs"/>
-              </a:defRPr>
-            </a:lvl2pPr>
-            <a:lvl3pPr marL="0" indent="0" algn="l" defTabSz="914407" rtl="0" eaLnBrk="1" latinLnBrk="0" hangingPunct="1">
-              <a:lnSpc>
-                <a:spcPct val="108000"/>
-              </a:lnSpc>
-              <a:spcBef>
-                <a:spcPts val="0"/>
-              </a:spcBef>
-              <a:spcAft>
-                <a:spcPts val="0"/>
-              </a:spcAft>
-              <a:buFont typeface="Arial" panose="020B0604020202020204" pitchFamily="34" charset="0"/>
-              <a:buNone/>
-              <a:tabLst>
-                <a:tab pos="288003" algn="l"/>
-                <a:tab pos="792005" algn="l"/>
-              </a:tabLst>
-              <a:defRPr sz="1999" b="0" kern="1200">
-                <a:solidFill>
-                  <a:schemeClr val="accent1"/>
-                </a:solidFill>
-                <a:latin typeface="+mn-lt"/>
-                <a:ea typeface="+mn-ea"/>
-                <a:cs typeface="+mn-cs"/>
-              </a:defRPr>
-            </a:lvl3pPr>
-            <a:lvl4pPr marL="288003" indent="0" algn="l" defTabSz="914407" rtl="0" eaLnBrk="1" latinLnBrk="0" hangingPunct="1">
-              <a:lnSpc>
-                <a:spcPct val="108000"/>
-              </a:lnSpc>
-              <a:spcBef>
-                <a:spcPts val="1300"/>
-              </a:spcBef>
-              <a:spcAft>
-                <a:spcPts val="0"/>
-              </a:spcAft>
-              <a:buFont typeface="Arial" panose="020B0604020202020204" pitchFamily="34" charset="0"/>
-              <a:buNone/>
-              <a:tabLst>
-                <a:tab pos="288003" algn="l"/>
-                <a:tab pos="792005" algn="l"/>
-              </a:tabLst>
-              <a:defRPr sz="1999" b="1" kern="1200">
-                <a:solidFill>
-                  <a:schemeClr val="tx1"/>
-                </a:solidFill>
-                <a:latin typeface="+mj-lt"/>
-                <a:ea typeface="+mn-ea"/>
-                <a:cs typeface="+mn-cs"/>
-              </a:defRPr>
-            </a:lvl4pPr>
-            <a:lvl5pPr marL="288003" indent="-288003" algn="l" defTabSz="914407" rtl="0" eaLnBrk="1" latinLnBrk="0" hangingPunct="1">
-              <a:lnSpc>
-                <a:spcPct val="108000"/>
-              </a:lnSpc>
-              <a:spcBef>
-                <a:spcPts val="0"/>
-              </a:spcBef>
-              <a:spcAft>
-                <a:spcPts val="0"/>
-              </a:spcAft>
-              <a:buClr>
-                <a:schemeClr val="accent1"/>
-              </a:buClr>
-              <a:buFont typeface="Arial" panose="020B0604020202020204" pitchFamily="34" charset="0"/>
-              <a:buChar char="&gt;"/>
-              <a:tabLst>
-                <a:tab pos="288003" algn="l"/>
-                <a:tab pos="792005" algn="l"/>
-              </a:tabLst>
-              <a:defRPr sz="1999" b="0" kern="1200">
-                <a:solidFill>
-                  <a:schemeClr val="tx1"/>
-                </a:solidFill>
-                <a:latin typeface="+mn-lt"/>
-                <a:ea typeface="+mn-ea"/>
-                <a:cs typeface="+mn-cs"/>
-              </a:defRPr>
-            </a:lvl5pPr>
-            <a:lvl6pPr marL="504004" indent="-216001" algn="l" defTabSz="914407" rtl="0" eaLnBrk="1" latinLnBrk="0" hangingPunct="1">
-              <a:lnSpc>
-                <a:spcPct val="108000"/>
-              </a:lnSpc>
-              <a:spcBef>
-                <a:spcPts val="0"/>
-              </a:spcBef>
-              <a:spcAft>
-                <a:spcPts val="0"/>
-              </a:spcAft>
-              <a:buFont typeface="Wingdings" panose="05000000000000000000" pitchFamily="2" charset="2"/>
-              <a:buChar char=""/>
-              <a:tabLst>
-                <a:tab pos="288003" algn="l"/>
-                <a:tab pos="792005" algn="l"/>
-              </a:tabLst>
-              <a:defRPr sz="1999" b="0" kern="1200">
-                <a:solidFill>
-                  <a:schemeClr val="tx1"/>
-                </a:solidFill>
-                <a:latin typeface="+mn-lt"/>
-                <a:ea typeface="+mn-ea"/>
-                <a:cs typeface="+mn-cs"/>
-              </a:defRPr>
-            </a:lvl6pPr>
-            <a:lvl7pPr marL="288003" indent="-288003" algn="l" defTabSz="914407" rtl="0" eaLnBrk="1" latinLnBrk="0" hangingPunct="1">
-              <a:lnSpc>
-                <a:spcPct val="108000"/>
-              </a:lnSpc>
-              <a:spcBef>
-                <a:spcPts val="0"/>
-              </a:spcBef>
-              <a:spcAft>
-                <a:spcPts val="0"/>
-              </a:spcAft>
-              <a:buFont typeface="+mj-lt"/>
-              <a:buAutoNum type="arabicPeriod"/>
-              <a:tabLst>
-                <a:tab pos="288003" algn="l"/>
-                <a:tab pos="792005" algn="l"/>
-              </a:tabLst>
-              <a:defRPr sz="1999" b="0" kern="1200">
-                <a:solidFill>
-                  <a:schemeClr val="tx1"/>
-                </a:solidFill>
-                <a:latin typeface="+mn-lt"/>
-                <a:ea typeface="+mn-ea"/>
-                <a:cs typeface="+mn-cs"/>
-              </a:defRPr>
-            </a:lvl7pPr>
-            <a:lvl8pPr marL="288003" indent="0" algn="l" defTabSz="914407" rtl="0" eaLnBrk="1" latinLnBrk="0" hangingPunct="1">
-              <a:lnSpc>
-                <a:spcPct val="108000"/>
-              </a:lnSpc>
-              <a:spcBef>
-                <a:spcPts val="0"/>
-              </a:spcBef>
-              <a:spcAft>
-                <a:spcPts val="0"/>
-              </a:spcAft>
-              <a:buFont typeface="Arial" panose="020B0604020202020204" pitchFamily="34" charset="0"/>
-              <a:buNone/>
-              <a:tabLst>
-                <a:tab pos="288003" algn="l"/>
-                <a:tab pos="792005" algn="l"/>
-              </a:tabLst>
-              <a:defRPr sz="1999" b="0" kern="1200">
-                <a:solidFill>
-                  <a:schemeClr val="tx1"/>
-                </a:solidFill>
-                <a:latin typeface="+mn-lt"/>
-                <a:ea typeface="+mn-ea"/>
-                <a:cs typeface="+mn-cs"/>
-              </a:defRPr>
-            </a:lvl8pPr>
-            <a:lvl9pPr marL="0" indent="0" algn="l" defTabSz="914407" rtl="0" eaLnBrk="1" latinLnBrk="0" hangingPunct="1">
-              <a:lnSpc>
-                <a:spcPct val="108000"/>
-              </a:lnSpc>
-              <a:spcBef>
-                <a:spcPts val="0"/>
-              </a:spcBef>
-              <a:spcAft>
-                <a:spcPts val="0"/>
-              </a:spcAft>
-              <a:buFont typeface="Arial" panose="020B0604020202020204" pitchFamily="34" charset="0"/>
-              <a:buNone/>
-              <a:tabLst>
-                <a:tab pos="288003" algn="l"/>
-                <a:tab pos="792005" algn="l"/>
-              </a:tabLst>
-              <a:defRPr sz="1999" b="0" kern="1200">
-                <a:solidFill>
-                  <a:schemeClr val="tx1"/>
-                </a:solidFill>
-                <a:latin typeface="+mn-lt"/>
-                <a:ea typeface="+mn-ea"/>
-                <a:cs typeface="+mn-cs"/>
-              </a:defRPr>
-            </a:lvl9pPr>
-          </a:lstStyle>
-          <a:p>
-            <a:pPr marL="0" lvl="6" indent="0">
-              <a:buNone/>
-            </a:pPr>
-            <a:endParaRPr lang="en-US" noProof="0" dirty="0"/>
-          </a:p>
-        </p:txBody>
-      </p:sp>
-      <p:sp>
-        <p:nvSpPr>
           <p:cNvPr id="11" name="Datumsplatzhalter 10">
             <a:extLst>
               <a:ext uri="{FF2B5EF4-FFF2-40B4-BE49-F238E27FC236}">
@@ -29808,22 +30246,21 @@
         </p:nvPicPr>
         <p:blipFill>
           <a:blip r:embed="rId2"/>
-          <a:stretch>
-            <a:fillRect/>
-          </a:stretch>
+          <a:srcRect/>
+          <a:stretch/>
         </p:blipFill>
         <p:spPr>
           <a:xfrm>
-            <a:off x="558804" y="2309498"/>
-            <a:ext cx="5283195" cy="3943254"/>
+            <a:off x="406397" y="2167048"/>
+            <a:ext cx="5184975" cy="4076593"/>
           </a:xfrm>
           <a:prstGeom prst="rect">
             <a:avLst/>
           </a:prstGeom>
         </p:spPr>
       </p:pic>
-      <mc:AlternateContent xmlns:mc="http://schemas.openxmlformats.org/markup-compatibility/2006">
-        <mc:Choice xmlns:a14="http://schemas.microsoft.com/office/drawing/2010/main" Requires="a14">
+      <mc:AlternateContent xmlns:mc="http://schemas.openxmlformats.org/markup-compatibility/2006" xmlns:a14="http://schemas.microsoft.com/office/drawing/2010/main">
+        <mc:Choice Requires="a14">
           <p:sp>
             <p:nvSpPr>
               <p:cNvPr id="8" name="Inhaltsplatzhalter 7">
@@ -29850,6 +30287,7 @@
               <a:bodyPr/>
               <a:lstStyle/>
               <a:p>
+                <a:pPr/>
                 <a:r>
                   <a:rPr lang="en-US" noProof="0" dirty="0"/>
                   <a:t>Since the classes are uniformly distributed, accuracy is an appropriate metric for model evaluation.</a:t>
@@ -29884,7 +30322,7 @@
                       <m:f>
                         <m:fPr>
                           <m:ctrlPr>
-                            <a:rPr lang="en-US" b="0" noProof="0" smtClean="0">
+                            <a:rPr lang="en-US" b="0" i="1" noProof="0" smtClean="0">
                               <a:latin typeface="Cambria Math" panose="02040503050406030204" pitchFamily="18" charset="0"/>
                             </a:rPr>
                           </m:ctrlPr>
@@ -29950,7 +30388,7 @@
             </p:txBody>
           </p:sp>
         </mc:Choice>
-        <mc:Fallback>
+        <mc:Fallback xmlns="">
           <p:sp>
             <p:nvSpPr>
               <p:cNvPr id="8" name="Inhaltsplatzhalter 7">
@@ -30157,10 +30595,10 @@
       </p:sp>
       <p:sp>
         <p:nvSpPr>
-          <p:cNvPr id="7" name="Vertikaler Textplatzhalter 6">
+          <p:cNvPr id="3" name="Textplatzhalter 2">
             <a:extLst>
               <a:ext uri="{FF2B5EF4-FFF2-40B4-BE49-F238E27FC236}">
-                <a16:creationId xmlns:a16="http://schemas.microsoft.com/office/drawing/2014/main" id="{353A59F3-B4FB-D517-5B26-1A5E86AEFA79}"/>
+                <a16:creationId xmlns:a16="http://schemas.microsoft.com/office/drawing/2014/main" id="{5D050554-109E-BA1B-219B-242E31F9AD70}"/>
               </a:ext>
             </a:extLst>
           </p:cNvPr>
@@ -30168,7 +30606,7 @@
             <a:spLocks noGrp="1"/>
           </p:cNvSpPr>
           <p:nvPr>
-            <p:ph type="body" orient="vert" idx="13"/>
+            <p:ph type="body" idx="13"/>
           </p:nvPr>
         </p:nvSpPr>
         <p:spPr/>
@@ -30176,10 +30614,7 @@
           <a:bodyPr/>
           <a:lstStyle/>
           <a:p>
-            <a:r>
-              <a:rPr lang="en-US" noProof="0" dirty="0"/>
-              <a:t>Trimming it down to the essentials.</a:t>
-            </a:r>
+            <a:endParaRPr lang="en-US"/>
           </a:p>
         </p:txBody>
       </p:sp>

</xml_diff>